<commit_message>
ooxml-epic-d-awm.19 regenerate reviewed cover-fit scaffold fixture with UPDATE_GOLDENS=1 code-first, batch-verify pending
</commit_message>
<xml_diff>
--- a/testdata/pptx/scaffold/eleven-layouts.pptx
+++ b/testdata/pptx/scaffold/eleven-layouts.pptx
@@ -2275,7 +2275,7 @@
       </p:grpSpPr>
       <p:pic>
         <p:nvPicPr>
-          <p:cNvPr id="2" name="Picture Placeholder 1"/>
+          <p:cNvPr id="2" name="Picture Placeholder 1" descr=""/>
           <p:cNvPicPr>
             <a:picLocks noChangeAspect="1"/>
           </p:cNvPicPr>
@@ -2283,7 +2283,10 @@
         </p:nvPicPr>
         <p:blipFill>
           <a:blip r:embed="rId2"/>
-          <a:tile tx="0" ty="0" sx="100000" sy="100000" flip="none" algn="ctr"/>
+          <a:srcRect l="0" t="13203" r="0" b="13203"/>
+          <a:stretch>
+            <a:fillRect/>
+          </a:stretch>
         </p:blipFill>
         <p:spPr>
           <a:xfrm>

</xml_diff>